<commit_message>
Target Sydney with On-Demand m7i-flex.large nodes by default
The cluster was applied in ap-southeast-2 on On-Demand m7i-flex.large
nodes, the only setup an AWS Free plan account allows. Make that the
Terraform and script default and update the docs, the cost table
(about $0.40/hour, $1.40/day saved by skipping NAT) and slide 6 of the
deck to match. Spot stays available as an option for paid accounts.
</commit_message>
<xml_diff>
--- a/docs/Shelfwise-presentation.pptx
+++ b/docs/Shelfwise-presentation.pptx
@@ -115,35 +115,35 @@
   <p:extLst>
     <p:ext uri="{521415D9-36F7-43E2-AB2F-B90AF26B5E84}">
       <p14:sectionLst xmlns:p14="http://schemas.microsoft.com/office/powerpoint/2010/main">
-        <p14:section name="Introduction" id="{1bc3bcf0-d397-56ea-cc9f-a4ee98585229}">
+        <p14:section name="Introduction" id="{586d2a9b-e0f1-f3fc-3dfa-b74ae6cf80c9}">
           <p14:sldIdLst>
             <p14:sldId id="256"/>
           </p14:sldIdLst>
         </p14:section>
-        <p14:section name="Application" id="{0fd53af5-8c9c-bed1-58a3-a2388e7acfbb}">
+        <p14:section name="Application" id="{82376cf2-2e71-2674-1b0b-bbad71651388}">
           <p14:sldIdLst>
             <p14:sldId id="257"/>
           </p14:sldIdLst>
         </p14:section>
-        <p14:section name="Delivery" id="{69cd3700-66b2-5443-54cb-1ea2a5286d37}">
+        <p14:section name="Delivery" id="{78dbd7e8-d68b-609d-d806-84dfc21be81c}">
           <p14:sldIdLst>
             <p14:sldId id="258"/>
             <p14:sldId id="259"/>
           </p14:sldIdLst>
         </p14:section>
-        <p14:section name="Platform" id="{9febde04-8555-78ee-08ee-162870937763}">
+        <p14:section name="Platform" id="{3ac70f8f-de30-d235-bd36-329241f264dc}">
           <p14:sldIdLst>
             <p14:sldId id="260"/>
             <p14:sldId id="261"/>
             <p14:sldId id="262"/>
           </p14:sldIdLst>
         </p14:section>
-        <p14:section name="Demo" id="{a41259aa-0a05-1143-33c5-2c1904b37373}">
+        <p14:section name="Demo" id="{a5478d96-3891-fd97-654b-7650876c40cd}">
           <p14:sldIdLst>
             <p14:sldId id="263"/>
           </p14:sldIdLst>
         </p14:section>
-        <p14:section name="Close" id="{51b1741b-5d42-fc23-346e-cee437181ac0}">
+        <p14:section name="Close" id="{1f8a99e0-1711-2ac0-9786-feb7e3b8806e}">
           <p14:sldIdLst>
             <p14:sldId id="264"/>
           </p14:sldIdLst>
@@ -992,7 +992,7 @@
           <a:p>
             <a:r>
               <a:rPr lang="en-US" dirty="0"/>
-              <a:t>terraform plan / apply / destroy screenshots are in docs/SUBMISSION.md (M7). The cluster only exists for the demo session.</a:t>
+              <a:t>terraform plan / apply / destroy screenshots are in docs/SUBMISSION.md (M7). Applied in Sydney (the only region a Free plan account allows), deployed, then destroyed: 24 resources, about $0.50 of credits.</a:t>
             </a:r>
             <a:endParaRPr lang="en-US" dirty="0"/>
           </a:p>
@@ -3785,7 +3785,7 @@
                   <a:schemeClr val="tx1"/>
                 </a:solidFill>
               </a:rPr>
-              <a:t>Image Updater writes the tag to the Argo CD Application, not to Git, so every one of the 45+ commits is mine.</a:t>
+              <a:t>Image Updater writes the tag to the Argo CD Application, not to Git, so every one of the 50+ commits is mine.</a:t>
             </a:r>
             <a:endParaRPr lang="en-US" sz="1600" dirty="0"/>
           </a:p>
@@ -5085,7 +5085,7 @@
                   <a:schemeClr val="accent1"/>
                 </a:solidFill>
               </a:rPr>
-              <a:t>VPC 10.42.0.0/16 · ap-south-1</a:t>
+              <a:t>VPC 10.42.0.0/16 · ap-southeast-2 (Sydney)</a:t>
             </a:r>
             <a:endParaRPr lang="en-US" sz="1400" dirty="0"/>
           </a:p>
@@ -5162,7 +5162,7 @@
                   <a:srgbClr val="5B554B"/>
                 </a:solidFill>
               </a:rPr>
-              <a:t>ap-south-1a · 10.42.0.0/20</a:t>
+              <a:t>ap-southeast-2a · 10.42.0.0/20</a:t>
             </a:r>
             <a:endParaRPr lang="en-US" sz="1400" dirty="0"/>
           </a:p>
@@ -5225,7 +5225,7 @@
                   <a:schemeClr val="accent1"/>
                 </a:solidFill>
               </a:rPr>
-              <a:t>EKS node · t3.medium Spot</a:t>
+              <a:t>EKS node · m7i-flex.large</a:t>
             </a:r>
             <a:endParaRPr lang="en-US" sz="1300" dirty="0"/>
           </a:p>
@@ -5302,7 +5302,7 @@
                   <a:srgbClr val="5B554B"/>
                 </a:solidFill>
               </a:rPr>
-              <a:t>ap-south-1b · 10.42.16.0/20</a:t>
+              <a:t>ap-southeast-2b · 10.42.16.0/20</a:t>
             </a:r>
             <a:endParaRPr lang="en-US" sz="1400" dirty="0"/>
           </a:p>
@@ -5365,7 +5365,7 @@
                   <a:schemeClr val="accent1"/>
                 </a:solidFill>
               </a:rPr>
-              <a:t>EKS node · t3.medium Spot</a:t>
+              <a:t>EKS node · m7i-flex.large</a:t>
             </a:r>
             <a:endParaRPr lang="en-US" sz="1300" dirty="0"/>
           </a:p>
@@ -5476,7 +5476,7 @@
                 <a:ea typeface="Cambria" pitchFamily="34" charset="-122"/>
                 <a:cs typeface="Cambria" pitchFamily="34" charset="-120"/>
               </a:rPr>
-              <a:t>≈ $0.16</a:t>
+              <a:t>≈ $0.40</a:t>
             </a:r>
             <a:endParaRPr lang="en-US" sz="5400" dirty="0"/>
           </a:p>
@@ -5512,7 +5512,7 @@
                   <a:schemeClr val="tx1"/>
                 </a:solidFill>
               </a:rPr>
-              <a:t>per hour while the cluster is up</a:t>
+              <a:t>per hour, paid from AWS credits ($0.50 in total)</a:t>
             </a:r>
             <a:endParaRPr lang="en-US" sz="1600" dirty="0"/>
           </a:p>
@@ -5552,7 +5552,7 @@
                   <a:schemeClr val="tx1"/>
                 </a:solidFill>
               </a:rPr>
-              <a:t>No NAT gateway: saves ~$1.10/day</a:t>
+              <a:t>No NAT gateway: saves ~$1.40/day</a:t>
             </a:r>
             <a:endParaRPr lang="en-US" sz="1500" dirty="0"/>
           </a:p>
@@ -5570,7 +5570,7 @@
                   <a:schemeClr val="tx1"/>
                 </a:solidFill>
               </a:rPr>
-              <a:t>Spot nodes: ~70% cheaper</a:t>
+              <a:t>Free plan: Sydney, On-Demand, Free Tier nodes</a:t>
             </a:r>
             <a:endParaRPr lang="en-US" sz="1500" dirty="0"/>
           </a:p>

</xml_diff>